<commit_message>
Add self-serve signup over the API, and fix a silent blank in scalar sections
A section over a truthy scalar pushed `undefined` as the scope, so {#note}{.}{/note}
rendered empty with no error - exactly the silent blank this product exists to
prevent. Mustache's own semantics are to push the scalar itself; now we do.

Co-Authored-By: Claude Opus 5 (1M context) <noreply@anthropic.com>
Claude-Session: https://claude.ai/code/session_018KEKXsLNnUHdwnAGmnMsHj
</commit_message>
<xml_diff>
--- a/fixtures/cards.pptx
+++ b/fixtures/cards.pptx
@@ -64,7 +64,7 @@
         <p:txBody>
           <a:bodyPr/>
           <a:p>
-            <a:fld id="{3EC8FDF7-ECC0-4E8C-9E56-9B0B3D6B58AB}" type="slidenum">
+            <a:fld id="{3B36BA42-8165-4355-B8E2-263F8CC3CD3D}" type="slidenum">
               <a:t>&lt;#&gt;</a:t>
             </a:fld>
           </a:p>
@@ -273,7 +273,7 @@
         <p:txBody>
           <a:bodyPr/>
           <a:p>
-            <a:fld id="{FDD64559-E507-4230-8A8E-A7B4D644656E}" type="slidenum">
+            <a:fld id="{57349C65-0F57-4B50-A3F5-25002241BC6D}" type="slidenum">
               <a:t>&lt;#&gt;</a:t>
             </a:fld>
           </a:p>
@@ -568,7 +568,7 @@
         <p:txBody>
           <a:bodyPr/>
           <a:p>
-            <a:fld id="{3B259B59-993D-458B-8EAD-39B3F2AE4EE4}" type="slidenum">
+            <a:fld id="{15028982-0D8A-4CC2-8BE5-FD38980BF57E}" type="slidenum">
               <a:t>&lt;#&gt;</a:t>
             </a:fld>
           </a:p>
@@ -949,7 +949,7 @@
         <p:txBody>
           <a:bodyPr/>
           <a:p>
-            <a:fld id="{78BA8BE9-1DB5-432F-BDB7-D3B1B3C55855}" type="slidenum">
+            <a:fld id="{A3CC2DEF-6CD0-403D-AC1D-D303720CB049}" type="slidenum">
               <a:t>&lt;#&gt;</a:t>
             </a:fld>
           </a:p>
@@ -1112,7 +1112,7 @@
         <p:txBody>
           <a:bodyPr/>
           <a:p>
-            <a:fld id="{DE64583F-545D-4A93-B04C-629B1B833905}" type="slidenum">
+            <a:fld id="{CE2AD6F2-D359-41BD-B8B6-A8AB941C6C85}" type="slidenum">
               <a:t>&lt;#&gt;</a:t>
             </a:fld>
           </a:p>
@@ -1278,7 +1278,7 @@
         <p:txBody>
           <a:bodyPr/>
           <a:p>
-            <a:fld id="{78D60F24-1A9E-47B2-B8B6-F05C8B7578BB}" type="slidenum">
+            <a:fld id="{E7E52947-2843-4456-956D-19804147C35E}" type="slidenum">
               <a:t>&lt;#&gt;</a:t>
             </a:fld>
           </a:p>
@@ -1487,7 +1487,7 @@
         <p:txBody>
           <a:bodyPr/>
           <a:p>
-            <a:fld id="{EA157A6F-4EFF-438F-9C15-4C0F1BF5CC09}" type="slidenum">
+            <a:fld id="{45CC3973-4C8E-482F-81D1-FB68C27C3C61}" type="slidenum">
               <a:t>&lt;#&gt;</a:t>
             </a:fld>
           </a:p>
@@ -1610,7 +1610,7 @@
         <p:txBody>
           <a:bodyPr/>
           <a:p>
-            <a:fld id="{4F8AE34E-6693-4DB9-BA3D-B10574DBC196}" type="slidenum">
+            <a:fld id="{01644EAC-245E-4902-8A06-F7E28A93B8BA}" type="slidenum">
               <a:t>&lt;#&gt;</a:t>
             </a:fld>
           </a:p>
@@ -1731,7 +1731,7 @@
         <p:txBody>
           <a:bodyPr/>
           <a:p>
-            <a:fld id="{EFCC04C7-3FA3-415C-999E-3543BA666D21}" type="slidenum">
+            <a:fld id="{ACB89878-2471-4580-A6D6-624749CCF633}" type="slidenum">
               <a:t>&lt;#&gt;</a:t>
             </a:fld>
           </a:p>
@@ -1983,7 +1983,7 @@
         <p:txBody>
           <a:bodyPr/>
           <a:p>
-            <a:fld id="{6CF4A1CB-5888-420E-BCDF-6728DD9B9B1C}" type="slidenum">
+            <a:fld id="{1CE80939-34B6-4F9E-BC11-86E8E136A30D}" type="slidenum">
               <a:t>&lt;#&gt;</a:t>
             </a:fld>
           </a:p>
@@ -2235,7 +2235,7 @@
         <p:txBody>
           <a:bodyPr/>
           <a:p>
-            <a:fld id="{7D5221E2-CE4B-46E9-9461-228AEBC7386A}" type="slidenum">
+            <a:fld id="{FA45AFA5-7C60-4283-8A62-834507B12A76}" type="slidenum">
               <a:t>&lt;#&gt;</a:t>
             </a:fld>
           </a:p>
@@ -2487,7 +2487,7 @@
         <p:txBody>
           <a:bodyPr/>
           <a:p>
-            <a:fld id="{E6893B08-7B8B-4035-B7B5-ADD0C8A382F4}" type="slidenum">
+            <a:fld id="{0C676CFB-74FD-4493-9AEB-AA58A5579F01}" type="slidenum">
               <a:t>&lt;#&gt;</a:t>
             </a:fld>
           </a:p>
@@ -2972,7 +2972,7 @@
             <a:pPr indent="0" algn="r">
               <a:buNone/>
             </a:pPr>
-            <a:fld id="{3F22A1FA-1B84-4CC3-9436-8EB862ADDC03}" type="slidenum">
+            <a:fld id="{0FA68487-0AF7-4CFB-BF53-66F338249FE3}" type="slidenum">
               <a:rPr b="0" lang="en-US" sz="1400" spc="-1" strike="noStrike">
                 <a:solidFill>
                   <a:srgbClr val="000000"/>

</xml_diff>

<commit_message>
Move the database to Frankfurt, and instrument healthz so query latency is answerable
The first production measurement showed 560 ms to load a template and 150 ms to
take a credit, between a service in Frankfurt and a database in Oregon. Moving the
Neon project to eu-central-1 was the obvious half of the fix; the other half is
that the remaining latency could not be diagnosed from outside the container, so
/healthz?db=1 now reports a round trip and the connection pool's counters.

Co-Authored-By: Claude Opus 5 (1M context) <noreply@anthropic.com>
Claude-Session: https://claude.ai/code/session_018KEKXsLNnUHdwnAGmnMsHj
</commit_message>
<xml_diff>
--- a/fixtures/cards.pptx
+++ b/fixtures/cards.pptx
@@ -4,13 +4,432 @@
   <p:sldMasterIdLst>
     <p:sldMasterId id="2147483648" r:id="rId2"/>
   </p:sldMasterIdLst>
+  <p:notesMasterIdLst>
+    <p:notesMasterId r:id="rId3"/>
+  </p:notesMasterIdLst>
   <p:sldIdLst>
-    <p:sldId id="256" r:id="rId3"/>
-    <p:sldId id="257" r:id="rId4"/>
+    <p:sldId id="256" r:id="rId4"/>
+    <p:sldId id="257" r:id="rId5"/>
   </p:sldIdLst>
   <p:sldSz cx="10080625" cy="5670550"/>
   <p:notesSz cx="7559675" cy="10691813"/>
 </p:presentation>
+</file>
+
+<file path=ppt/notesMasters/notesMaster1.xml><?xml version="1.0" encoding="utf-8"?>
+<p:notesMaster xmlns:a="http://schemas.openxmlformats.org/drawingml/2006/main" xmlns:p="http://schemas.openxmlformats.org/presentationml/2006/main" xmlns:r="http://schemas.openxmlformats.org/officeDocument/2006/relationships" xmlns:p14="http://schemas.microsoft.com/office/powerpoint/2010/main" xmlns:p15="http://schemas.microsoft.com/office/powerpoint/2012/main" xmlns:mc="http://schemas.openxmlformats.org/markup-compatibility/2006">
+  <p:cSld>
+    <p:spTree>
+      <p:nvGrpSpPr>
+        <p:cNvPr id="1" name=""/>
+        <p:cNvGrpSpPr/>
+        <p:nvPr/>
+      </p:nvGrpSpPr>
+      <p:grpSpPr>
+        <a:xfrm>
+          <a:off x="0" y="0"/>
+          <a:ext cx="0" cy="0"/>
+          <a:chOff x="0" y="0"/>
+          <a:chExt cx="0" cy="0"/>
+        </a:xfrm>
+      </p:grpSpPr>
+      <p:sp>
+        <p:nvSpPr>
+          <p:cNvPr id="41" name="PlaceHolder 1"/>
+          <p:cNvSpPr>
+            <a:spLocks noGrp="1"/>
+          </p:cNvSpPr>
+          <p:nvPr>
+            <p:ph type="sldImg"/>
+          </p:nvPr>
+        </p:nvSpPr>
+        <p:spPr>
+          <a:xfrm>
+            <a:off x="216000" y="812520"/>
+            <a:ext cx="7127280" cy="4008960"/>
+          </a:xfrm>
+          <a:prstGeom prst="rect">
+            <a:avLst/>
+          </a:prstGeom>
+          <a:noFill/>
+          <a:ln w="0">
+            <a:noFill/>
+          </a:ln>
+        </p:spPr>
+        <p:txBody>
+          <a:bodyPr lIns="0" rIns="0" tIns="0" bIns="0" anchor="ctr">
+            <a:noAutofit/>
+          </a:bodyPr>
+          <a:p>
+            <a:pPr algn="ctr"/>
+            <a:r>
+              <a:rPr b="0" lang="en-US" sz="4400" spc="-1" strike="noStrike">
+                <a:solidFill>
+                  <a:srgbClr val="000000"/>
+                </a:solidFill>
+                <a:latin typeface="Arial"/>
+              </a:rPr>
+              <a:t>Click to move the slide</a:t>
+            </a:r>
+            <a:endParaRPr b="0" lang="en-US" sz="4400" spc="-1" strike="noStrike">
+              <a:solidFill>
+                <a:srgbClr val="000000"/>
+              </a:solidFill>
+              <a:latin typeface="Arial"/>
+            </a:endParaRPr>
+          </a:p>
+        </p:txBody>
+      </p:sp>
+      <p:sp>
+        <p:nvSpPr>
+          <p:cNvPr id="42" name="PlaceHolder 2"/>
+          <p:cNvSpPr>
+            <a:spLocks noGrp="1"/>
+          </p:cNvSpPr>
+          <p:nvPr>
+            <p:ph type="body"/>
+          </p:nvPr>
+        </p:nvSpPr>
+        <p:spPr>
+          <a:xfrm>
+            <a:off x="756000" y="5078520"/>
+            <a:ext cx="6047640" cy="4811040"/>
+          </a:xfrm>
+          <a:prstGeom prst="rect">
+            <a:avLst/>
+          </a:prstGeom>
+          <a:noFill/>
+          <a:ln w="0">
+            <a:noFill/>
+          </a:ln>
+        </p:spPr>
+        <p:txBody>
+          <a:bodyPr lIns="0" rIns="0" tIns="0" bIns="0" anchor="t">
+            <a:noAutofit/>
+          </a:bodyPr>
+          <a:p>
+            <a:pPr marL="216000" indent="0">
+              <a:buNone/>
+            </a:pPr>
+            <a:r>
+              <a:rPr b="0" lang="en-US" sz="2000" spc="-1" strike="noStrike">
+                <a:solidFill>
+                  <a:srgbClr val="000000"/>
+                </a:solidFill>
+                <a:latin typeface="Arial"/>
+              </a:rPr>
+              <a:t>Click to edit the notes format</a:t>
+            </a:r>
+            <a:endParaRPr b="0" lang="en-US" sz="2000" spc="-1" strike="noStrike">
+              <a:solidFill>
+                <a:srgbClr val="000000"/>
+              </a:solidFill>
+              <a:latin typeface="Arial"/>
+            </a:endParaRPr>
+          </a:p>
+        </p:txBody>
+      </p:sp>
+      <p:sp>
+        <p:nvSpPr>
+          <p:cNvPr id="43" name="PlaceHolder 3"/>
+          <p:cNvSpPr>
+            <a:spLocks noGrp="1"/>
+          </p:cNvSpPr>
+          <p:nvPr>
+            <p:ph type="hdr"/>
+          </p:nvPr>
+        </p:nvSpPr>
+        <p:spPr>
+          <a:xfrm>
+            <a:off x="0" y="0"/>
+            <a:ext cx="3280680" cy="534240"/>
+          </a:xfrm>
+          <a:prstGeom prst="rect">
+            <a:avLst/>
+          </a:prstGeom>
+          <a:noFill/>
+          <a:ln w="0">
+            <a:noFill/>
+          </a:ln>
+        </p:spPr>
+        <p:txBody>
+          <a:bodyPr lIns="0" rIns="0" tIns="0" bIns="0" anchor="t">
+            <a:noAutofit/>
+          </a:bodyPr>
+          <a:p>
+            <a:pPr indent="0">
+              <a:buNone/>
+            </a:pPr>
+            <a:r>
+              <a:rPr b="0" lang="en-US" sz="1400" spc="-1" strike="noStrike">
+                <a:solidFill>
+                  <a:srgbClr val="000000"/>
+                </a:solidFill>
+                <a:latin typeface="Times New Roman"/>
+              </a:rPr>
+              <a:t>&lt;header&gt;</a:t>
+            </a:r>
+            <a:endParaRPr b="0" lang="en-US" sz="1400" spc="-1" strike="noStrike">
+              <a:solidFill>
+                <a:srgbClr val="000000"/>
+              </a:solidFill>
+              <a:latin typeface="Times New Roman"/>
+            </a:endParaRPr>
+          </a:p>
+        </p:txBody>
+      </p:sp>
+      <p:sp>
+        <p:nvSpPr>
+          <p:cNvPr id="44" name="PlaceHolder 4"/>
+          <p:cNvSpPr>
+            <a:spLocks noGrp="1"/>
+          </p:cNvSpPr>
+          <p:nvPr>
+            <p:ph type="dt" idx="4"/>
+          </p:nvPr>
+        </p:nvSpPr>
+        <p:spPr>
+          <a:xfrm>
+            <a:off x="4278960" y="0"/>
+            <a:ext cx="3280680" cy="534240"/>
+          </a:xfrm>
+          <a:prstGeom prst="rect">
+            <a:avLst/>
+          </a:prstGeom>
+          <a:noFill/>
+          <a:ln w="0">
+            <a:noFill/>
+          </a:ln>
+        </p:spPr>
+        <p:txBody>
+          <a:bodyPr lIns="0" rIns="0" tIns="0" bIns="0" anchor="t">
+            <a:noAutofit/>
+          </a:bodyPr>
+          <a:lstStyle>
+            <a:lvl1pPr indent="0" algn="r">
+              <a:buNone/>
+              <a:defRPr b="0" lang="en-US" sz="1400" spc="-1" strike="noStrike">
+                <a:solidFill>
+                  <a:srgbClr val="000000"/>
+                </a:solidFill>
+                <a:latin typeface="Times New Roman"/>
+              </a:defRPr>
+            </a:lvl1pPr>
+          </a:lstStyle>
+          <a:p>
+            <a:pPr indent="0" algn="r">
+              <a:buNone/>
+            </a:pPr>
+            <a:r>
+              <a:rPr b="0" lang="en-US" sz="1400" spc="-1" strike="noStrike">
+                <a:solidFill>
+                  <a:srgbClr val="000000"/>
+                </a:solidFill>
+                <a:latin typeface="Times New Roman"/>
+              </a:rPr>
+              <a:t>&lt;date/time&gt;</a:t>
+            </a:r>
+            <a:endParaRPr b="0" lang="en-US" sz="1400" spc="-1" strike="noStrike">
+              <a:solidFill>
+                <a:srgbClr val="000000"/>
+              </a:solidFill>
+              <a:latin typeface="Times New Roman"/>
+            </a:endParaRPr>
+          </a:p>
+        </p:txBody>
+      </p:sp>
+      <p:sp>
+        <p:nvSpPr>
+          <p:cNvPr id="45" name="PlaceHolder 5"/>
+          <p:cNvSpPr>
+            <a:spLocks noGrp="1"/>
+          </p:cNvSpPr>
+          <p:nvPr>
+            <p:ph type="ftr" idx="5"/>
+          </p:nvPr>
+        </p:nvSpPr>
+        <p:spPr>
+          <a:xfrm>
+            <a:off x="0" y="10157400"/>
+            <a:ext cx="3280680" cy="534240"/>
+          </a:xfrm>
+          <a:prstGeom prst="rect">
+            <a:avLst/>
+          </a:prstGeom>
+          <a:noFill/>
+          <a:ln w="0">
+            <a:noFill/>
+          </a:ln>
+        </p:spPr>
+        <p:txBody>
+          <a:bodyPr lIns="0" rIns="0" tIns="0" bIns="0" anchor="b">
+            <a:noAutofit/>
+          </a:bodyPr>
+          <a:lstStyle>
+            <a:lvl1pPr indent="0">
+              <a:buNone/>
+              <a:defRPr b="0" lang="en-US" sz="1400" spc="-1" strike="noStrike">
+                <a:solidFill>
+                  <a:srgbClr val="000000"/>
+                </a:solidFill>
+                <a:latin typeface="Times New Roman"/>
+              </a:defRPr>
+            </a:lvl1pPr>
+          </a:lstStyle>
+          <a:p>
+            <a:pPr indent="0">
+              <a:buNone/>
+            </a:pPr>
+            <a:r>
+              <a:rPr b="0" lang="en-US" sz="1400" spc="-1" strike="noStrike">
+                <a:solidFill>
+                  <a:srgbClr val="000000"/>
+                </a:solidFill>
+                <a:latin typeface="Times New Roman"/>
+              </a:rPr>
+              <a:t>&lt;footer&gt;</a:t>
+            </a:r>
+            <a:endParaRPr b="0" lang="en-US" sz="1400" spc="-1" strike="noStrike">
+              <a:solidFill>
+                <a:srgbClr val="000000"/>
+              </a:solidFill>
+              <a:latin typeface="Times New Roman"/>
+            </a:endParaRPr>
+          </a:p>
+        </p:txBody>
+      </p:sp>
+      <p:sp>
+        <p:nvSpPr>
+          <p:cNvPr id="46" name="PlaceHolder 6"/>
+          <p:cNvSpPr>
+            <a:spLocks noGrp="1"/>
+          </p:cNvSpPr>
+          <p:nvPr>
+            <p:ph type="sldNum" idx="6"/>
+          </p:nvPr>
+        </p:nvSpPr>
+        <p:spPr>
+          <a:xfrm>
+            <a:off x="4278960" y="10157400"/>
+            <a:ext cx="3280680" cy="534240"/>
+          </a:xfrm>
+          <a:prstGeom prst="rect">
+            <a:avLst/>
+          </a:prstGeom>
+          <a:noFill/>
+          <a:ln w="0">
+            <a:noFill/>
+          </a:ln>
+        </p:spPr>
+        <p:txBody>
+          <a:bodyPr lIns="0" rIns="0" tIns="0" bIns="0" anchor="b">
+            <a:noAutofit/>
+          </a:bodyPr>
+          <a:lstStyle>
+            <a:lvl1pPr indent="0" algn="r">
+              <a:buNone/>
+              <a:defRPr b="0" lang="en-US" sz="1400" spc="-1" strike="noStrike">
+                <a:solidFill>
+                  <a:srgbClr val="000000"/>
+                </a:solidFill>
+                <a:latin typeface="Times New Roman"/>
+              </a:defRPr>
+            </a:lvl1pPr>
+          </a:lstStyle>
+          <a:p>
+            <a:pPr indent="0" algn="r">
+              <a:buNone/>
+            </a:pPr>
+            <a:fld id="{CE3A5C27-25E6-4755-9C8B-D225701EC575}" type="slidenum">
+              <a:rPr b="0" lang="en-US" sz="1400" spc="-1" strike="noStrike">
+                <a:solidFill>
+                  <a:srgbClr val="000000"/>
+                </a:solidFill>
+                <a:latin typeface="Times New Roman"/>
+              </a:rPr>
+              <a:t>&lt;number&gt;</a:t>
+            </a:fld>
+            <a:endParaRPr b="0" lang="en-US" sz="1400" spc="-1" strike="noStrike">
+              <a:solidFill>
+                <a:srgbClr val="000000"/>
+              </a:solidFill>
+              <a:latin typeface="Times New Roman"/>
+            </a:endParaRPr>
+          </a:p>
+        </p:txBody>
+      </p:sp>
+    </p:spTree>
+  </p:cSld>
+  <p:clrMap bg1="lt1" bg2="lt2" tx1="dk1" tx2="dk2" accent1="accent1" accent2="accent2" accent3="accent3" accent4="accent4" accent5="accent5" accent6="accent6" hlink="hlink" folHlink="folHlink"/>
+</p:notesMaster>
+</file>
+
+<file path=ppt/notesSlides/notesSlide2.xml><?xml version="1.0" encoding="utf-8"?>
+<p:notes xmlns:a="http://schemas.openxmlformats.org/drawingml/2006/main" xmlns:p="http://schemas.openxmlformats.org/presentationml/2006/main" xmlns:r="http://schemas.openxmlformats.org/officeDocument/2006/relationships" xmlns:p14="http://schemas.microsoft.com/office/powerpoint/2010/main" xmlns:p15="http://schemas.microsoft.com/office/powerpoint/2012/main" xmlns:mc="http://schemas.openxmlformats.org/markup-compatibility/2006">
+  <p:cSld>
+    <p:spTree>
+      <p:nvGrpSpPr>
+        <p:cNvPr id="1" name=""/>
+        <p:cNvGrpSpPr/>
+        <p:nvPr/>
+      </p:nvGrpSpPr>
+      <p:grpSpPr>
+        <a:xfrm>
+          <a:off x="0" y="0"/>
+          <a:ext cx="0" cy="0"/>
+          <a:chOff x="0" y="0"/>
+          <a:chExt cx="0" cy="0"/>
+        </a:xfrm>
+      </p:grpSpPr>
+      <p:sp>
+        <p:nvSpPr>
+          <p:cNvPr id="52" name="Card Notes"/>
+          <p:cNvSpPr txBox="1"/>
+          <p:nvPr/>
+        </p:nvSpPr>
+        <p:spPr>
+          <a:xfrm>
+            <a:off x="720000" y="3600000"/>
+            <a:ext cx="5040000" cy="2160000"/>
+          </a:xfrm>
+          <a:prstGeom prst="rect">
+            <a:avLst/>
+          </a:prstGeom>
+          <a:solidFill>
+            <a:srgbClr val="729fcf"/>
+          </a:solidFill>
+          <a:ln w="0">
+            <a:solidFill>
+              <a:srgbClr val="3465a4"/>
+            </a:solidFill>
+          </a:ln>
+        </p:spPr>
+        <p:txBody>
+          <a:bodyPr lIns="90000" rIns="90000" tIns="45000" bIns="45000" anchor="t">
+            <a:noAutofit/>
+          </a:bodyPr>
+          <a:p>
+            <a:r>
+              <a:rPr b="0" lang="en-US" sz="1800" spc="-1" strike="noStrike">
+                <a:solidFill>
+                  <a:srgbClr val="000000"/>
+                </a:solidFill>
+                <a:latin typeface="Arial"/>
+              </a:rPr>
+              <a:t>Speaker notes for {label}</a:t>
+            </a:r>
+            <a:endParaRPr b="0" lang="en-US" sz="1800" spc="-1" strike="noStrike">
+              <a:solidFill>
+                <a:srgbClr val="000000"/>
+              </a:solidFill>
+              <a:latin typeface="Arial"/>
+            </a:endParaRPr>
+          </a:p>
+        </p:txBody>
+      </p:sp>
+    </p:spTree>
+  </p:cSld>
+</p:notes>
 </file>
 
 <file path=ppt/slideLayouts/slideLayout1.xml><?xml version="1.0" encoding="utf-8"?>
@@ -64,7 +483,7 @@
         <p:txBody>
           <a:bodyPr/>
           <a:p>
-            <a:fld id="{3B36BA42-8165-4355-B8E2-263F8CC3CD3D}" type="slidenum">
+            <a:fld id="{B33A961B-6DE0-48F0-9F4E-E26C979AF65E}" type="slidenum">
               <a:t>&lt;#&gt;</a:t>
             </a:fld>
           </a:p>
@@ -273,7 +692,7 @@
         <p:txBody>
           <a:bodyPr/>
           <a:p>
-            <a:fld id="{57349C65-0F57-4B50-A3F5-25002241BC6D}" type="slidenum">
+            <a:fld id="{C9EC61B3-C8CC-4C62-B15C-A7A2F37D7746}" type="slidenum">
               <a:t>&lt;#&gt;</a:t>
             </a:fld>
           </a:p>
@@ -568,7 +987,7 @@
         <p:txBody>
           <a:bodyPr/>
           <a:p>
-            <a:fld id="{15028982-0D8A-4CC2-8BE5-FD38980BF57E}" type="slidenum">
+            <a:fld id="{3E1FB0AF-7D62-4AA0-B304-C54BEFCEF764}" type="slidenum">
               <a:t>&lt;#&gt;</a:t>
             </a:fld>
           </a:p>
@@ -949,7 +1368,7 @@
         <p:txBody>
           <a:bodyPr/>
           <a:p>
-            <a:fld id="{A3CC2DEF-6CD0-403D-AC1D-D303720CB049}" type="slidenum">
+            <a:fld id="{724DE00D-1527-4C23-B36D-EE5C05D06218}" type="slidenum">
               <a:t>&lt;#&gt;</a:t>
             </a:fld>
           </a:p>
@@ -1112,7 +1531,7 @@
         <p:txBody>
           <a:bodyPr/>
           <a:p>
-            <a:fld id="{CE2AD6F2-D359-41BD-B8B6-A8AB941C6C85}" type="slidenum">
+            <a:fld id="{3EFA9192-C702-4024-9636-39EA54486C0F}" type="slidenum">
               <a:t>&lt;#&gt;</a:t>
             </a:fld>
           </a:p>
@@ -1278,7 +1697,7 @@
         <p:txBody>
           <a:bodyPr/>
           <a:p>
-            <a:fld id="{E7E52947-2843-4456-956D-19804147C35E}" type="slidenum">
+            <a:fld id="{1A994C15-8792-46BC-87FB-D347B0A6A075}" type="slidenum">
               <a:t>&lt;#&gt;</a:t>
             </a:fld>
           </a:p>
@@ -1487,7 +1906,7 @@
         <p:txBody>
           <a:bodyPr/>
           <a:p>
-            <a:fld id="{45CC3973-4C8E-482F-81D1-FB68C27C3C61}" type="slidenum">
+            <a:fld id="{9E9FAB75-CAB8-44D0-B4F5-0A2E165328A8}" type="slidenum">
               <a:t>&lt;#&gt;</a:t>
             </a:fld>
           </a:p>
@@ -1610,7 +2029,7 @@
         <p:txBody>
           <a:bodyPr/>
           <a:p>
-            <a:fld id="{01644EAC-245E-4902-8A06-F7E28A93B8BA}" type="slidenum">
+            <a:fld id="{B967F14B-2F94-458B-B124-577700BE60AF}" type="slidenum">
               <a:t>&lt;#&gt;</a:t>
             </a:fld>
           </a:p>
@@ -1731,7 +2150,7 @@
         <p:txBody>
           <a:bodyPr/>
           <a:p>
-            <a:fld id="{ACB89878-2471-4580-A6D6-624749CCF633}" type="slidenum">
+            <a:fld id="{4B6A614F-60C2-4B70-AE05-0CE9E3BF14D7}" type="slidenum">
               <a:t>&lt;#&gt;</a:t>
             </a:fld>
           </a:p>
@@ -1983,7 +2402,7 @@
         <p:txBody>
           <a:bodyPr/>
           <a:p>
-            <a:fld id="{1CE80939-34B6-4F9E-BC11-86E8E136A30D}" type="slidenum">
+            <a:fld id="{E71ECD48-1309-49CF-BD24-EE3234683CF0}" type="slidenum">
               <a:t>&lt;#&gt;</a:t>
             </a:fld>
           </a:p>
@@ -2235,7 +2654,7 @@
         <p:txBody>
           <a:bodyPr/>
           <a:p>
-            <a:fld id="{FA45AFA5-7C60-4283-8A62-834507B12A76}" type="slidenum">
+            <a:fld id="{CE22F130-9BE7-4F25-B5F2-3BBC6E150CF9}" type="slidenum">
               <a:t>&lt;#&gt;</a:t>
             </a:fld>
           </a:p>
@@ -2487,7 +2906,7 @@
         <p:txBody>
           <a:bodyPr/>
           <a:p>
-            <a:fld id="{0C676CFB-74FD-4493-9AEB-AA58A5579F01}" type="slidenum">
+            <a:fld id="{B54AA2A8-528D-460E-99F6-1AC14F2F537A}" type="slidenum">
               <a:t>&lt;#&gt;</a:t>
             </a:fld>
           </a:p>
@@ -2972,7 +3391,7 @@
             <a:pPr indent="0" algn="r">
               <a:buNone/>
             </a:pPr>
-            <a:fld id="{0FA68487-0AF7-4CFB-BF53-66F338249FE3}" type="slidenum">
+            <a:fld id="{67A15171-517A-4342-8062-4215897E9564}" type="slidenum">
               <a:rPr b="0" lang="en-US" sz="1400" spc="-1" strike="noStrike">
                 <a:solidFill>
                   <a:srgbClr val="000000"/>
@@ -3029,7 +3448,7 @@
       </p:grpSpPr>
       <p:sp>
         <p:nvSpPr>
-          <p:cNvPr id="41" name="Title 1"/>
+          <p:cNvPr id="47" name="Title 1"/>
           <p:cNvSpPr txBox="1"/>
           <p:nvPr/>
         </p:nvSpPr>
@@ -3105,7 +3524,7 @@
       </p:grpSpPr>
       <p:sp>
         <p:nvSpPr>
-          <p:cNvPr id="42" name="Loop Open"/>
+          <p:cNvPr id="48" name="Loop Open"/>
           <p:cNvSpPr txBox="1"/>
           <p:nvPr/>
         </p:nvSpPr>
@@ -3151,7 +3570,7 @@
       </p:sp>
       <p:sp>
         <p:nvSpPr>
-          <p:cNvPr id="43" name="Card Heading"/>
+          <p:cNvPr id="49" name="Card Heading"/>
           <p:cNvSpPr txBox="1"/>
           <p:nvPr/>
         </p:nvSpPr>
@@ -3197,7 +3616,7 @@
       </p:sp>
       <p:sp>
         <p:nvSpPr>
-          <p:cNvPr id="44" name="Card Body"/>
+          <p:cNvPr id="50" name="Card Body"/>
           <p:cNvSpPr txBox="1"/>
           <p:nvPr/>
         </p:nvSpPr>
@@ -3260,7 +3679,7 @@
       </p:sp>
       <p:sp>
         <p:nvSpPr>
-          <p:cNvPr id="45" name="Loop Close"/>
+          <p:cNvPr id="51" name="Loop Close"/>
           <p:cNvSpPr txBox="1"/>
           <p:nvPr/>
         </p:nvSpPr>
@@ -3529,4 +3948,218 @@
     </a:fmtScheme>
   </a:themeElements>
 </a:theme>
+</file>
+
+<file path=ppt/theme/theme2.xml><?xml version="1.0" encoding="utf-8"?>
+<a:theme xmlns:a="http://schemas.openxmlformats.org/drawingml/2006/main" name="Office Theme">
+  <a:themeElements>
+    <a:clrScheme name="Office">
+      <a:dk1>
+        <a:sysClr val="windowText" lastClr="000000"/>
+      </a:dk1>
+      <a:lt1>
+        <a:sysClr val="window" lastClr="FFFFFF"/>
+      </a:lt1>
+      <a:dk2>
+        <a:srgbClr val="1f497d"/>
+      </a:dk2>
+      <a:lt2>
+        <a:srgbClr val="eeece1"/>
+      </a:lt2>
+      <a:accent1>
+        <a:srgbClr val="4f81bd"/>
+      </a:accent1>
+      <a:accent2>
+        <a:srgbClr val="c0504d"/>
+      </a:accent2>
+      <a:accent3>
+        <a:srgbClr val="9bbb59"/>
+      </a:accent3>
+      <a:accent4>
+        <a:srgbClr val="8064a2"/>
+      </a:accent4>
+      <a:accent5>
+        <a:srgbClr val="4bacc6"/>
+      </a:accent5>
+      <a:accent6>
+        <a:srgbClr val="f79646"/>
+      </a:accent6>
+      <a:hlink>
+        <a:srgbClr val="0000ff"/>
+      </a:hlink>
+      <a:folHlink>
+        <a:srgbClr val="800080"/>
+      </a:folHlink>
+    </a:clrScheme>
+    <a:fontScheme name="Office">
+      <a:majorFont>
+        <a:latin typeface="Arial"/>
+        <a:ea typeface="DejaVu Sans"/>
+        <a:cs typeface="DejaVu Sans"/>
+      </a:majorFont>
+      <a:minorFont>
+        <a:latin typeface="Arial"/>
+        <a:ea typeface="DejaVu Sans"/>
+        <a:cs typeface="DejaVu Sans"/>
+      </a:minorFont>
+    </a:fontScheme>
+    <a:fmtScheme name="Office">
+      <a:fillStyleLst>
+        <a:solidFill>
+          <a:schemeClr val="phClr"/>
+        </a:solidFill>
+        <a:gradFill rotWithShape="1">
+          <a:gsLst>
+            <a:gs pos="0">
+              <a:schemeClr val="phClr">
+                <a:tint val="50000"/>
+                <a:satMod val="300000"/>
+              </a:schemeClr>
+            </a:gs>
+            <a:gs pos="35000">
+              <a:schemeClr val="phClr">
+                <a:tint val="37000"/>
+                <a:satMod val="300000"/>
+              </a:schemeClr>
+            </a:gs>
+            <a:gs pos="100000">
+              <a:schemeClr val="phClr">
+                <a:tint val="15000"/>
+                <a:satMod val="350000"/>
+              </a:schemeClr>
+            </a:gs>
+          </a:gsLst>
+          <a:lin ang="16200000" scaled="1"/>
+        </a:gradFill>
+        <a:gradFill rotWithShape="1">
+          <a:gsLst>
+            <a:gs pos="0">
+              <a:schemeClr val="phClr">
+                <a:shade val="51000"/>
+                <a:satMod val="130000"/>
+              </a:schemeClr>
+            </a:gs>
+            <a:gs pos="80000">
+              <a:schemeClr val="phClr">
+                <a:shade val="93000"/>
+                <a:satMod val="130000"/>
+              </a:schemeClr>
+            </a:gs>
+            <a:gs pos="100000">
+              <a:schemeClr val="phClr">
+                <a:shade val="94000"/>
+                <a:satMod val="135000"/>
+              </a:schemeClr>
+            </a:gs>
+          </a:gsLst>
+          <a:lin ang="16200000" scaled="0"/>
+        </a:gradFill>
+      </a:fillStyleLst>
+      <a:lnStyleLst>
+        <a:ln w="6350" cap="flat" cmpd="sng" algn="ctr">
+          <a:solidFill>
+            <a:schemeClr val="phClr">
+              <a:shade val="95000"/>
+              <a:satMod val="105000"/>
+            </a:schemeClr>
+          </a:solidFill>
+          <a:prstDash val="solid"/>
+          <a:miter/>
+        </a:ln>
+        <a:ln w="12700" cap="flat" cmpd="sng" algn="ctr">
+          <a:solidFill>
+            <a:schemeClr val="phClr"/>
+          </a:solidFill>
+          <a:prstDash val="solid"/>
+          <a:miter/>
+        </a:ln>
+        <a:ln w="19050" cap="flat" cmpd="sng" algn="ctr">
+          <a:solidFill>
+            <a:schemeClr val="phClr"/>
+          </a:solidFill>
+          <a:prstDash val="solid"/>
+          <a:miter/>
+        </a:ln>
+      </a:lnStyleLst>
+      <a:effectStyleLst>
+        <a:effectStyle>
+          <a:effectLst/>
+        </a:effectStyle>
+        <a:effectStyle>
+          <a:effectLst/>
+        </a:effectStyle>
+        <a:effectStyle>
+          <a:effectLst>
+            <a:outerShdw blurRad="40000" dist="23000" dir="5400000" rotWithShape="0">
+              <a:srgbClr val="000000">
+                <a:alpha val="35000"/>
+              </a:srgbClr>
+            </a:outerShdw>
+          </a:effectLst>
+          <a:scene3d>
+            <a:camera prst="orthographicFront">
+              <a:rot lat="0" lon="0" rev="0"/>
+            </a:camera>
+            <a:lightRig rig="threePt" dir="t">
+              <a:rot lat="0" lon="0" rev="1200000"/>
+            </a:lightRig>
+          </a:scene3d>
+          <a:sp3d>
+            <a:bevelT w="63500" h="25400"/>
+          </a:sp3d>
+        </a:effectStyle>
+      </a:effectStyleLst>
+      <a:bgFillStyleLst>
+        <a:solidFill>
+          <a:schemeClr val="phClr"/>
+        </a:solidFill>
+        <a:gradFill rotWithShape="1">
+          <a:gsLst>
+            <a:gs pos="0">
+              <a:schemeClr val="phClr">
+                <a:tint val="40000"/>
+                <a:satMod val="350000"/>
+              </a:schemeClr>
+            </a:gs>
+            <a:gs pos="40000">
+              <a:schemeClr val="phClr">
+                <a:tint val="45000"/>
+                <a:shade val="99000"/>
+                <a:satMod val="350000"/>
+              </a:schemeClr>
+            </a:gs>
+            <a:gs pos="100000">
+              <a:schemeClr val="phClr">
+                <a:shade val="20000"/>
+                <a:satMod val="255000"/>
+              </a:schemeClr>
+            </a:gs>
+          </a:gsLst>
+          <a:path path="circle">
+            <a:fillToRect l="50000" t="-80000" r="50000" b="180000"/>
+          </a:path>
+        </a:gradFill>
+        <a:gradFill rotWithShape="1">
+          <a:gsLst>
+            <a:gs pos="0">
+              <a:schemeClr val="phClr">
+                <a:tint val="80000"/>
+                <a:satMod val="300000"/>
+              </a:schemeClr>
+            </a:gs>
+            <a:gs pos="100000">
+              <a:schemeClr val="phClr">
+                <a:shade val="30000"/>
+                <a:satMod val="200000"/>
+              </a:schemeClr>
+            </a:gs>
+          </a:gsLst>
+          <a:path path="circle">
+            <a:fillToRect l="50000" t="50000" r="50000" b="50000"/>
+          </a:path>
+        </a:gradFill>
+      </a:bgFillStyleLst>
+    </a:fmtScheme>
+  </a:themeElements>
+</a:theme>
 </file>
</xml_diff>

<commit_message>
Renderers for DOCX, XLSX and PPTX, and make the spreadsheet share the render context
xlsx.js built its own template context, so every resolved_from_outer_scope warning
the dispatcher collects was silently dropped for spreadsheets. Filling the invoice
fixture with a root-level "note", where {note} sits inside the {#items} loop,
now reports it against cell Invoice!A6 instead of saying nothing.

128 tests pass, including LibreOffice round trips that check the arithmetic.

Co-Authored-By: Claude Opus 5 (1M context) <noreply@anthropic.com>
Claude-Session: https://claude.ai/code/session_018KEKXsLNnUHdwnAGmnMsHj
</commit_message>
<xml_diff>
--- a/fixtures/cards.pptx
+++ b/fixtures/cards.pptx
@@ -340,7 +340,7 @@
             <a:pPr indent="0" algn="r">
               <a:buNone/>
             </a:pPr>
-            <a:fld id="{CE3A5C27-25E6-4755-9C8B-D225701EC575}" type="slidenum">
+            <a:fld id="{350BDE31-714B-4FD3-B34A-8DE1467CEC67}" type="slidenum">
               <a:rPr b="0" lang="en-US" sz="1400" spc="-1" strike="noStrike">
                 <a:solidFill>
                   <a:srgbClr val="000000"/>
@@ -483,7 +483,7 @@
         <p:txBody>
           <a:bodyPr/>
           <a:p>
-            <a:fld id="{B33A961B-6DE0-48F0-9F4E-E26C979AF65E}" type="slidenum">
+            <a:fld id="{AD77E237-625F-469C-BB2B-3B93FD92CE28}" type="slidenum">
               <a:t>&lt;#&gt;</a:t>
             </a:fld>
           </a:p>
@@ -692,7 +692,7 @@
         <p:txBody>
           <a:bodyPr/>
           <a:p>
-            <a:fld id="{C9EC61B3-C8CC-4C62-B15C-A7A2F37D7746}" type="slidenum">
+            <a:fld id="{8809F03C-3DB6-4DCB-9758-127C7C597D52}" type="slidenum">
               <a:t>&lt;#&gt;</a:t>
             </a:fld>
           </a:p>
@@ -987,7 +987,7 @@
         <p:txBody>
           <a:bodyPr/>
           <a:p>
-            <a:fld id="{3E1FB0AF-7D62-4AA0-B304-C54BEFCEF764}" type="slidenum">
+            <a:fld id="{B53F41C9-F0B5-4398-AF5C-3BA017CA5190}" type="slidenum">
               <a:t>&lt;#&gt;</a:t>
             </a:fld>
           </a:p>
@@ -1368,7 +1368,7 @@
         <p:txBody>
           <a:bodyPr/>
           <a:p>
-            <a:fld id="{724DE00D-1527-4C23-B36D-EE5C05D06218}" type="slidenum">
+            <a:fld id="{E334B292-B897-4934-B239-951250096B29}" type="slidenum">
               <a:t>&lt;#&gt;</a:t>
             </a:fld>
           </a:p>
@@ -1531,7 +1531,7 @@
         <p:txBody>
           <a:bodyPr/>
           <a:p>
-            <a:fld id="{3EFA9192-C702-4024-9636-39EA54486C0F}" type="slidenum">
+            <a:fld id="{726BFADD-6F0F-4508-9813-E954194B232A}" type="slidenum">
               <a:t>&lt;#&gt;</a:t>
             </a:fld>
           </a:p>
@@ -1697,7 +1697,7 @@
         <p:txBody>
           <a:bodyPr/>
           <a:p>
-            <a:fld id="{1A994C15-8792-46BC-87FB-D347B0A6A075}" type="slidenum">
+            <a:fld id="{E3E39574-FF24-4AC9-92E1-3CD88C5E5410}" type="slidenum">
               <a:t>&lt;#&gt;</a:t>
             </a:fld>
           </a:p>
@@ -1906,7 +1906,7 @@
         <p:txBody>
           <a:bodyPr/>
           <a:p>
-            <a:fld id="{9E9FAB75-CAB8-44D0-B4F5-0A2E165328A8}" type="slidenum">
+            <a:fld id="{A9075FCD-99DC-4333-926B-0B998D357D57}" type="slidenum">
               <a:t>&lt;#&gt;</a:t>
             </a:fld>
           </a:p>
@@ -2029,7 +2029,7 @@
         <p:txBody>
           <a:bodyPr/>
           <a:p>
-            <a:fld id="{B967F14B-2F94-458B-B124-577700BE60AF}" type="slidenum">
+            <a:fld id="{30B24B2F-0C2C-41D6-BAF8-D86A8C666537}" type="slidenum">
               <a:t>&lt;#&gt;</a:t>
             </a:fld>
           </a:p>
@@ -2150,7 +2150,7 @@
         <p:txBody>
           <a:bodyPr/>
           <a:p>
-            <a:fld id="{4B6A614F-60C2-4B70-AE05-0CE9E3BF14D7}" type="slidenum">
+            <a:fld id="{22A82363-B17C-439B-80C9-F610CC9A1D3A}" type="slidenum">
               <a:t>&lt;#&gt;</a:t>
             </a:fld>
           </a:p>
@@ -2402,7 +2402,7 @@
         <p:txBody>
           <a:bodyPr/>
           <a:p>
-            <a:fld id="{E71ECD48-1309-49CF-BD24-EE3234683CF0}" type="slidenum">
+            <a:fld id="{82B86AB6-9454-45D1-9220-2D4624E90FB3}" type="slidenum">
               <a:t>&lt;#&gt;</a:t>
             </a:fld>
           </a:p>
@@ -2654,7 +2654,7 @@
         <p:txBody>
           <a:bodyPr/>
           <a:p>
-            <a:fld id="{CE22F130-9BE7-4F25-B5F2-3BBC6E150CF9}" type="slidenum">
+            <a:fld id="{A2801FC6-AFCE-4F60-9704-D208B5005E6E}" type="slidenum">
               <a:t>&lt;#&gt;</a:t>
             </a:fld>
           </a:p>
@@ -2906,7 +2906,7 @@
         <p:txBody>
           <a:bodyPr/>
           <a:p>
-            <a:fld id="{B54AA2A8-528D-460E-99F6-1AC14F2F537A}" type="slidenum">
+            <a:fld id="{3506F61F-5A15-4741-837B-88EDCAF068D0}" type="slidenum">
               <a:t>&lt;#&gt;</a:t>
             </a:fld>
           </a:p>
@@ -3391,7 +3391,7 @@
             <a:pPr indent="0" algn="r">
               <a:buNone/>
             </a:pPr>
-            <a:fld id="{67A15171-517A-4342-8062-4215897E9564}" type="slidenum">
+            <a:fld id="{34CB45E7-35C8-4F89-B460-5B11D7AA9399}" type="slidenum">
               <a:rPr b="0" lang="en-US" sz="1400" spc="-1" strike="noStrike">
                 <a:solidFill>
                   <a:srgbClr val="000000"/>

</xml_diff>